<commit_message>
Revamp CI pipeline: PHP images, tests & deploys
Overhaul .gitlab-ci.yml to modernize the CI/CD pipeline: switch to php:8.2 images, introduce a php-setup anchor, and install PHP extensions and composer in jobs. Generate .env in CI for install, unit and e2e jobs, adjust cache key, and change artifact/coverage handling. Add SonarCloud scanner, trivy filesystem and image scans, and a k6 smoke test job that captures results. Replace SSH-based staging/production deploys with self-hosted PowerShell-based Docker deployment jobs (staging and production), add build-image and trivy-image-scan steps, and update job dependencies/needs and allow_failure semantics. Misc: rename/clean test jobs, improve logs/artifacts retention, and update various scripts/healthchecks. Also includes a binary change to presentation-LPMDE.pptx.
</commit_message>
<xml_diff>
--- a/presentation-LPMDE.pptx
+++ b/presentation-LPMDE.pptx
@@ -2703,6 +2703,53 @@
           </a:p>
         </p:txBody>
       </p:sp>
+      <p:pic>
+        <p:nvPicPr>
+          <p:cNvPr id="1026" name="Picture 2" descr="École d'ingénieurs, bachelor et Mastère Spécialisé® - CESI">
+            <a:extLst>
+              <a:ext uri="{FF2B5EF4-FFF2-40B4-BE49-F238E27FC236}">
+                <a16:creationId xmlns:a16="http://schemas.microsoft.com/office/drawing/2014/main" id="{1406EA59-F64E-B226-0856-075F6440A4AD}"/>
+              </a:ext>
+            </a:extLst>
+          </p:cNvPr>
+          <p:cNvPicPr>
+            <a:picLocks noChangeAspect="1" noChangeArrowheads="1"/>
+          </p:cNvPicPr>
+          <p:nvPr/>
+        </p:nvPicPr>
+        <p:blipFill>
+          <a:blip r:embed="rId3">
+            <a:extLst>
+              <a:ext uri="{28A0092B-C50C-407E-A947-70E740481C1C}">
+                <a14:useLocalDpi xmlns:a14="http://schemas.microsoft.com/office/drawing/2010/main" val="0"/>
+              </a:ext>
+            </a:extLst>
+          </a:blip>
+          <a:srcRect/>
+          <a:stretch>
+            <a:fillRect/>
+          </a:stretch>
+        </p:blipFill>
+        <p:spPr bwMode="auto">
+          <a:xfrm>
+            <a:off x="10789920" y="199292"/>
+            <a:ext cx="1160585" cy="1160585"/>
+          </a:xfrm>
+          <a:prstGeom prst="rect">
+            <a:avLst/>
+          </a:prstGeom>
+          <a:noFill/>
+          <a:extLst>
+            <a:ext uri="{909E8E84-426E-40DD-AFC4-6F175D3DCCD1}">
+              <a14:hiddenFill xmlns:a14="http://schemas.microsoft.com/office/drawing/2010/main">
+                <a:solidFill>
+                  <a:srgbClr val="FFFFFF"/>
+                </a:solidFill>
+              </a14:hiddenFill>
+            </a:ext>
+          </a:extLst>
+        </p:spPr>
+      </p:pic>
     </p:spTree>
   </p:cSld>
   <p:clrMapOvr>

</xml_diff>